<commit_message>
Agregar el mapa del módulo y elegir el desafío entre casos reales
guias/mapa-del-modulo.md reúne lo que se espera en cada entrega, del
desafío al examen. Los desafíos salen de casos de organizaciones reales
que entrega el docente; README de la Clase 01, lámina 29 y AGENTS.md
ajustados.

Co-Authored-By: Claude Opus 5.5 <noreply@anthropic.com>
Claude-Session: https://claude.ai/code/session_01G8ZMAoyjRuPjQDimMZxkaQ
</commit_message>
<xml_diff>
--- a/clases/semana-01/01/ppt/Clase-01-Un-Software-Para-Alguien-Real.pptx
+++ b/clases/semana-01/01/ppt/Clase-01-Un-Software-Para-Alguien-Real.pptx
@@ -29841,7 +29841,7 @@
                 <a:ea typeface="Aptos Display" pitchFamily="34" charset="-122"/>
                 <a:cs typeface="Aptos Display" pitchFamily="34" charset="-120"/>
               </a:rPr>
-              <a:t>El desafío lo propone cada equipo</a:t>
+              <a:t>El desafío sale de un caso real</a:t>
             </a:r>
             <a:endParaRPr lang="en-US" sz="2800" dirty="0"/>
           </a:p>
@@ -29883,7 +29883,7 @@
                 <a:ea typeface="Aptos" pitchFamily="34" charset="-122"/>
                 <a:cs typeface="Aptos" pitchFamily="34" charset="-120"/>
               </a:rPr>
-              <a:t>El desafío es la necesidad real que va a resolver el equipo. Puede salir del negocio de un familiar, de un lugar de trabajo, de una institución del barrio o de un problema que el equipo haya visto.</a:t>
+              <a:t>El desafío es la necesidad real que va a resolver el equipo. Los desafíos salen de casos de organizaciones reales de la zona, que entrega el docente, y cada equipo elige uno.</a:t>
             </a:r>
             <a:endParaRPr lang="en-US" sz="1400" dirty="0"/>
           </a:p>
@@ -29986,7 +29986,7 @@
                 <a:ea typeface="Aptos" pitchFamily="34" charset="-122"/>
                 <a:cs typeface="Aptos" pitchFamily="34" charset="-120"/>
               </a:rPr>
-              <a:t>La organización existe</a:t>
+              <a:t>Se puede conversar con la organización</a:t>
             </a:r>
             <a:endParaRPr lang="en-US" sz="1400" dirty="0"/>
           </a:p>
@@ -30025,7 +30025,7 @@
                 <a:ea typeface="Aptos" pitchFamily="34" charset="-122"/>
                 <a:cs typeface="Aptos" pitchFamily="34" charset="-120"/>
               </a:rPr>
-              <a:t>No es un caso inventado.</a:t>
+              <a:t>Para levantar datos: entrevistas, encuestas, observación.</a:t>
             </a:r>
             <a:endParaRPr lang="en-US" sz="1150" dirty="0"/>
           </a:p>
@@ -30128,7 +30128,7 @@
                 <a:ea typeface="Aptos" pitchFamily="34" charset="-122"/>
                 <a:cs typeface="Aptos" pitchFamily="34" charset="-120"/>
               </a:rPr>
-              <a:t>Se puede conversar con ella</a:t>
+              <a:t>Pide software de verdad</a:t>
             </a:r>
             <a:endParaRPr lang="en-US" sz="1400" dirty="0"/>
           </a:p>
@@ -30167,7 +30167,7 @@
                 <a:ea typeface="Aptos" pitchFamily="34" charset="-122"/>
                 <a:cs typeface="Aptos" pitchFamily="34" charset="-120"/>
               </a:rPr>
-              <a:t>Para levantar datos: entrevistas, encuestas, observación.</a:t>
+              <a:t>No se resuelve con una planilla.</a:t>
             </a:r>
             <a:endParaRPr lang="en-US" sz="1150" dirty="0"/>
           </a:p>
@@ -30270,7 +30270,7 @@
                 <a:ea typeface="Aptos" pitchFamily="34" charset="-122"/>
                 <a:cs typeface="Aptos" pitchFamily="34" charset="-120"/>
               </a:rPr>
-              <a:t>Deja ver las herramientas de la carrera</a:t>
+              <a:t>Deja ver las herramientas del equipo</a:t>
             </a:r>
             <a:endParaRPr lang="en-US" sz="1400" dirty="0"/>
           </a:p>

</xml_diff>

<commit_message>
Dejar la Clase 01 independiente del origen de los desafíos
La lámina 29 pasa a «Qué hace bueno a un desafío», venga de donde venga.
El deck, el README de la clase y el mapa del módulo ya no dicen quién
entrega los desafíos ni cómo se forman los equipos.

Co-Authored-By: Claude Opus 5.5 <noreply@anthropic.com>
Claude-Session: https://claude.ai/code/session_01G8ZMAoyjRuPjQDimMZxkaQ
</commit_message>
<xml_diff>
--- a/clases/semana-01/01/ppt/Clase-01-Un-Software-Para-Alguien-Real.pptx
+++ b/clases/semana-01/01/ppt/Clase-01-Un-Software-Para-Alguien-Real.pptx
@@ -18146,7 +18146,7 @@
                 <a:ea typeface="Aptos" pitchFamily="34" charset="-122"/>
                 <a:cs typeface="Aptos" pitchFamily="34" charset="-120"/>
               </a:rPr>
-              <a:t>Desde la próxima, cada sesión es un taller sobre el proyecto de tu equipo.</a:t>
+              <a:t>Desde la próxima, cada sesión es un taller sobre el proyecto.</a:t>
             </a:r>
             <a:endParaRPr lang="en-US" sz="1400" dirty="0"/>
           </a:p>
@@ -26051,7 +26051,7 @@
                 <a:ea typeface="Aptos" pitchFamily="34" charset="-122"/>
                 <a:cs typeface="Aptos" pitchFamily="34" charset="-120"/>
               </a:rPr>
-              <a:t>El perfil de egreso de tu carrera, lo que te dejó cada asignatura, y para qué sirve saberlo: elegir el desafío de tu equipo.</a:t>
+              <a:t>El perfil de egreso de tu carrera, lo que te dejó cada asignatura, y para qué sirve saberlo: el desafío del proyecto.</a:t>
             </a:r>
             <a:endParaRPr lang="en-US" sz="1600" dirty="0"/>
           </a:p>
@@ -29841,7 +29841,7 @@
                 <a:ea typeface="Aptos Display" pitchFamily="34" charset="-122"/>
                 <a:cs typeface="Aptos Display" pitchFamily="34" charset="-120"/>
               </a:rPr>
-              <a:t>El desafío sale de un caso real</a:t>
+              <a:t>Qué hace bueno a un desafío</a:t>
             </a:r>
             <a:endParaRPr lang="en-US" sz="2800" dirty="0"/>
           </a:p>
@@ -29883,7 +29883,7 @@
                 <a:ea typeface="Aptos" pitchFamily="34" charset="-122"/>
                 <a:cs typeface="Aptos" pitchFamily="34" charset="-120"/>
               </a:rPr>
-              <a:t>El desafío es la necesidad real que va a resolver el equipo. Los desafíos salen de casos de organizaciones reales de la zona, que entrega el docente, y cada equipo elige uno.</a:t>
+              <a:t>El desafío es la necesidad real que va a resolver el proyecto. Venga de donde venga, un buen desafío cumple tres condiciones.</a:t>
             </a:r>
             <a:endParaRPr lang="en-US" sz="1400" dirty="0"/>
           </a:p>
@@ -29986,7 +29986,7 @@
                 <a:ea typeface="Aptos" pitchFamily="34" charset="-122"/>
                 <a:cs typeface="Aptos" pitchFamily="34" charset="-120"/>
               </a:rPr>
-              <a:t>Se puede conversar con la organización</a:t>
+              <a:t>Es una necesidad real de una organización</a:t>
             </a:r>
             <a:endParaRPr lang="en-US" sz="1400" dirty="0"/>
           </a:p>
@@ -30025,7 +30025,7 @@
                 <a:ea typeface="Aptos" pitchFamily="34" charset="-122"/>
                 <a:cs typeface="Aptos" pitchFamily="34" charset="-120"/>
               </a:rPr>
-              <a:t>Para levantar datos: entrevistas, encuestas, observación.</a:t>
+              <a:t>Existe fuera de la sala y alguien la vive todos los días.</a:t>
             </a:r>
             <a:endParaRPr lang="en-US" sz="1150" dirty="0"/>
           </a:p>
@@ -30128,7 +30128,7 @@
                 <a:ea typeface="Aptos" pitchFamily="34" charset="-122"/>
                 <a:cs typeface="Aptos" pitchFamily="34" charset="-120"/>
               </a:rPr>
-              <a:t>Pide software de verdad</a:t>
+              <a:t>Se pueden reunir datos sobre ella</a:t>
             </a:r>
             <a:endParaRPr lang="en-US" sz="1400" dirty="0"/>
           </a:p>
@@ -30167,7 +30167,7 @@
                 <a:ea typeface="Aptos" pitchFamily="34" charset="-122"/>
                 <a:cs typeface="Aptos" pitchFamily="34" charset="-120"/>
               </a:rPr>
-              <a:t>No se resuelve con una planilla.</a:t>
+              <a:t>Conversando con quienes la viven: entrevistas, encuestas, observación.</a:t>
             </a:r>
             <a:endParaRPr lang="en-US" sz="1150" dirty="0"/>
           </a:p>
@@ -30270,7 +30270,7 @@
                 <a:ea typeface="Aptos" pitchFamily="34" charset="-122"/>
                 <a:cs typeface="Aptos" pitchFamily="34" charset="-120"/>
               </a:rPr>
-              <a:t>Deja ver las herramientas del equipo</a:t>
+              <a:t>Deja ver las herramientas de la carrera</a:t>
             </a:r>
             <a:endParaRPr lang="en-US" sz="1400" dirty="0"/>
           </a:p>
@@ -30585,7 +30585,7 @@
                 <a:ea typeface="Aptos" pitchFamily="34" charset="-122"/>
                 <a:cs typeface="Aptos" pitchFamily="34" charset="-120"/>
               </a:rPr>
-              <a:t>Del desafío elegido parte el diagnóstico de la semana 2.</a:t>
+              <a:t>El desafío es el punto de partida del diagnóstico, la primera parte de la propuesta.</a:t>
             </a:r>
             <a:endParaRPr lang="en-US" sz="1400" dirty="0"/>
           </a:p>
@@ -33205,7 +33205,7 @@
                 <a:ea typeface="Aptos" pitchFamily="34" charset="-122"/>
                 <a:cs typeface="Aptos" pitchFamily="34" charset="-120"/>
               </a:rPr>
-              <a:t>Lo que sigue: formar los equipos y elegir el desafío.</a:t>
+              <a:t>Lo que sigue: definir el desafío de cada proyecto.</a:t>
             </a:r>
             <a:endParaRPr lang="en-US" sz="1600" dirty="0"/>
           </a:p>
@@ -34013,7 +34013,7 @@
                 <a:ea typeface="Aptos" pitchFamily="34" charset="-122"/>
                 <a:cs typeface="Aptos" pitchFamily="34" charset="-120"/>
               </a:rPr>
-              <a:t>De lo que tu equipo construye y documenta</a:t>
+              <a:t>De lo que se construye y se documenta</a:t>
             </a:r>
             <a:endParaRPr lang="en-US" sz="1250" dirty="0"/>
           </a:p>
@@ -35709,7 +35709,7 @@
                 <a:ea typeface="Aptos" pitchFamily="34" charset="-122"/>
                 <a:cs typeface="Aptos" pitchFamily="34" charset="-120"/>
               </a:rPr>
-              <a:t>Este caso aparece en todo el módulo para mostrar cada etapa con algo concreto. Es solo una ilustración: cada equipo trabaja con su propio desafío.</a:t>
+              <a:t>Este caso aparece en todo el módulo para mostrar cada etapa con algo concreto. Es solo una ilustración: cada proyecto trabaja con su propio desafío.</a:t>
             </a:r>
             <a:endParaRPr lang="en-US" sz="1300" dirty="0"/>
           </a:p>

</xml_diff>

<commit_message>
Permitir avances con supuestos y agregar demo e infografía del módulo
</commit_message>
<xml_diff>
--- a/clases/semana-01/01/ppt/Clase-01-Un-Software-Para-Alguien-Real.pptx
+++ b/clases/semana-01/01/ppt/Clase-01-Un-Software-Para-Alguien-Real.pptx
@@ -35,9 +35,10 @@
     <p:sldId id="283" r:id="rId29"/>
     <p:sldId id="284" r:id="rId30"/>
     <p:sldId id="285" r:id="rId31"/>
+    <p:sldId id="286" r:id="rId32"/>
   </p:sldIdLst>
   <p:notesMasterIdLst>
-    <p:notesMasterId r:id="rId32"/>
+    <p:notesMasterId r:id="rId33"/>
   </p:notesMasterIdLst>
   <p:sldSz cx="12192000" cy="6858000"/>
   <p:notesSz cx="6858000" cy="12192000"/>
@@ -2579,6 +2580,94 @@
             <a:fld id="{F7021451-1387-4CA6-816F-3879F97B5CBC}" type="slidenum">
               <a:rPr lang="en-US"/>
               <a:t>30</a:t>
+            </a:fld>
+            <a:endParaRPr lang="en-US"/>
+          </a:p>
+        </p:txBody>
+      </p:sp>
+    </p:spTree>
+    <p:extLst>
+      <p:ext uri="{BB962C8B-B14F-4D97-AF65-F5344CB8AC3E}">
+        <p14:creationId xmlns:p14="http://schemas.microsoft.com/office/powerpoint/2010/main" val="1024086991"/>
+      </p:ext>
+    </p:extLst>
+  </p:cSld>
+  <p:clrMapOvr>
+    <a:masterClrMapping/>
+  </p:clrMapOvr>
+</p:notes>
+</file>
+
+<file path=ppt/notesSlides/notesSlide31.xml><?xml version="1.0" encoding="utf-8"?>
+<p:notes xmlns:a="http://schemas.openxmlformats.org/drawingml/2006/main" xmlns:r="http://schemas.openxmlformats.org/officeDocument/2006/relationships" xmlns:p="http://schemas.openxmlformats.org/presentationml/2006/main">
+  <p:cSld>
+    <p:spTree>
+      <p:nvGrpSpPr>
+        <p:cNvPr id="1" name=""/>
+        <p:cNvGrpSpPr/>
+        <p:nvPr/>
+      </p:nvGrpSpPr>
+      <p:grpSpPr>
+        <a:xfrm>
+          <a:off x="0" y="0"/>
+          <a:ext cx="0" cy="0"/>
+          <a:chOff x="0" y="0"/>
+          <a:chExt cx="0" cy="0"/>
+        </a:xfrm>
+      </p:grpSpPr>
+      <p:sp>
+        <p:nvSpPr>
+          <p:cNvPr id="2" name="Slide Image Placeholder 1"/>
+          <p:cNvSpPr>
+            <a:spLocks noGrp="1" noRot="1" noChangeAspect="1"/>
+          </p:cNvSpPr>
+          <p:nvPr>
+            <p:ph type="sldImg"/>
+          </p:nvPr>
+        </p:nvSpPr>
+        <p:spPr/>
+      </p:sp>
+      <p:sp>
+        <p:nvSpPr>
+          <p:cNvPr id="3" name="Notes Placeholder 2"/>
+          <p:cNvSpPr>
+            <a:spLocks noGrp="1"/>
+          </p:cNvSpPr>
+          <p:nvPr>
+            <p:ph type="body" idx="1"/>
+          </p:nvPr>
+        </p:nvSpPr>
+        <p:spPr/>
+        <p:txBody>
+          <a:bodyPr/>
+          <a:lstStyle/>
+          <a:p>
+            <a:r>
+              <a:rPr lang="en-US" dirty="0"/>
+              <a:t/>
+            </a:r>
+            <a:endParaRPr lang="en-US" dirty="0"/>
+          </a:p>
+        </p:txBody>
+      </p:sp>
+      <p:sp>
+        <p:nvSpPr>
+          <p:cNvPr id="4" name="Slide Number Placeholder 3"/>
+          <p:cNvSpPr>
+            <a:spLocks noGrp="1"/>
+          </p:cNvSpPr>
+          <p:nvPr>
+            <p:ph type="sldNum" sz="quarter" idx="10"/>
+          </p:nvPr>
+        </p:nvSpPr>
+        <p:spPr/>
+        <p:txBody>
+          <a:bodyPr/>
+          <a:lstStyle/>
+          <a:p>
+            <a:fld id="{F7021451-1387-4CA6-816F-3879F97B5CBC}" type="slidenum">
+              <a:rPr lang="en-US"/>
+              <a:t>31</a:t>
             </a:fld>
             <a:endParaRPr lang="en-US"/>
           </a:p>
@@ -4722,7 +4811,7 @@
                 <a:ea typeface="Aptos" pitchFamily="34" charset="-122"/>
                 <a:cs typeface="Aptos" pitchFamily="34" charset="-120"/>
               </a:rPr>
-              <a:t>Entrevistar al dueño, mirar cómo se toma un pedido y contar cuántos se pierden por semana</a:t>
+              <a:t>Analizar el caso y fuentes, explicitar supuestos; entrevistar si se habilita el contacto</a:t>
             </a:r>
             <a:endParaRPr lang="en-US" sz="1300" dirty="0"/>
           </a:p>
@@ -5377,7 +5466,7 @@
                 <a:ea typeface="Aptos" pitchFamily="34" charset="-122"/>
                 <a:cs typeface="Aptos" pitchFamily="34" charset="-120"/>
               </a:rPr>
-              <a:t>Instalarlo en el mesón y enseñarles a los vendedores a usarlo</a:t>
+              <a:t>Instalar y probar en un entorno de demostración; en el mesón si se habilita el acceso</a:t>
             </a:r>
             <a:endParaRPr lang="en-US" sz="1300" dirty="0"/>
           </a:p>
@@ -7994,7 +8083,7 @@
                 <a:ea typeface="Aptos" pitchFamily="34" charset="-122"/>
                 <a:cs typeface="Aptos" pitchFamily="34" charset="-120"/>
               </a:rPr>
-              <a:t>Cómo funciona hoy la organización y qué le falla, con datos</a:t>
+              <a:t>Cómo funciona hoy; datos y supuestos diferenciados</a:t>
             </a:r>
             <a:endParaRPr lang="en-US" sz="1180" dirty="0"/>
           </a:p>
@@ -8100,7 +8189,7 @@
                 <a:ea typeface="Aptos" pitchFamily="34" charset="-122"/>
                 <a:cs typeface="Aptos" pitchFamily="34" charset="-120"/>
               </a:rPr>
-              <a:t>40 pedidos al día; 3 perdidos por semana</a:t>
+              <a:t>40 pedidos al día: supuesto por validar</a:t>
             </a:r>
             <a:endParaRPr lang="en-US" sz="1080" dirty="0"/>
           </a:p>
@@ -21058,7 +21147,7 @@
                 <a:ea typeface="Aptos" pitchFamily="34" charset="-122"/>
                 <a:cs typeface="Aptos" pitchFamily="34" charset="-120"/>
               </a:rPr>
-              <a:t>Entrevistas, encuestas, cotizaciones, matriz FODA</a:t>
+              <a:t>Fuentes, supuestos, cotizaciones, FODA y pruebas; entrevistas si se realizaron</a:t>
             </a:r>
             <a:endParaRPr lang="en-US" sz="1200" dirty="0"/>
           </a:p>
@@ -30128,7 +30217,7 @@
                 <a:ea typeface="Aptos" pitchFamily="34" charset="-122"/>
                 <a:cs typeface="Aptos" pitchFamily="34" charset="-120"/>
               </a:rPr>
-              <a:t>Se pueden reunir datos sobre ella</a:t>
+              <a:t>Se puede analizar con la información disponible</a:t>
             </a:r>
             <a:endParaRPr lang="en-US" sz="1400" dirty="0"/>
           </a:p>
@@ -30167,7 +30256,7 @@
                 <a:ea typeface="Aptos" pitchFamily="34" charset="-122"/>
                 <a:cs typeface="Aptos" pitchFamily="34" charset="-120"/>
               </a:rPr>
-              <a:t>Conversando con quienes la viven: entrevistas, encuestas, observación.</a:t>
+              <a:t>Caso, fuentes citadas y supuestos explícitos pendientes de validar.</a:t>
             </a:r>
             <a:endParaRPr lang="en-US" sz="1150" dirty="0"/>
           </a:p>
@@ -30585,7 +30674,7 @@
                 <a:ea typeface="Aptos" pitchFamily="34" charset="-122"/>
                 <a:cs typeface="Aptos" pitchFamily="34" charset="-120"/>
               </a:rPr>
-              <a:t>El desafío es el punto de partida del diagnóstico, la primera parte de la propuesta.</a:t>
+              <a:t>El contacto inmediato no es condición para elegir el desafío ni para comenzar.</a:t>
             </a:r>
             <a:endParaRPr lang="en-US" sz="1400" dirty="0"/>
           </a:p>
@@ -32113,6 +32202,717 @@
     <p:bg>
       <p:bgPr>
         <a:solidFill>
+          <a:srgbClr val="F8F3EC"/>
+        </a:solidFill>
+      </p:bgPr>
+    </p:bg>
+    <p:spTree>
+      <p:nvGrpSpPr>
+        <p:cNvPr id="1" name=""/>
+        <p:cNvGrpSpPr/>
+        <p:nvPr/>
+      </p:nvGrpSpPr>
+      <p:grpSpPr>
+        <a:xfrm>
+          <a:off x="0" y="0"/>
+          <a:ext cx="0" cy="0"/>
+          <a:chOff x="0" y="0"/>
+          <a:chExt cx="0" cy="0"/>
+        </a:xfrm>
+      </p:grpSpPr>
+      <p:sp>
+        <p:nvSpPr>
+          <p:cNvPr id="2" name="Shape 0"/>
+          <p:cNvSpPr/>
+          <p:nvPr/>
+        </p:nvSpPr>
+        <p:spPr>
+          <a:xfrm>
+            <a:off x="0" y="0"/>
+            <a:ext cx="658368" cy="109728"/>
+          </a:xfrm>
+          <a:prstGeom prst="rect">
+            <a:avLst/>
+          </a:prstGeom>
+          <a:solidFill>
+            <a:srgbClr val="D62027"/>
+          </a:solidFill>
+          <a:ln w="12700">
+            <a:solidFill>
+              <a:srgbClr val="D62027"/>
+            </a:solidFill>
+            <a:prstDash val="solid"/>
+          </a:ln>
+        </p:spPr>
+      </p:sp>
+      <p:sp>
+        <p:nvSpPr>
+          <p:cNvPr id="3" name="Shape 1"/>
+          <p:cNvSpPr/>
+          <p:nvPr/>
+        </p:nvSpPr>
+        <p:spPr>
+          <a:xfrm>
+            <a:off x="749808" y="0"/>
+            <a:ext cx="402336" cy="109728"/>
+          </a:xfrm>
+          <a:prstGeom prst="rect">
+            <a:avLst/>
+          </a:prstGeom>
+          <a:solidFill>
+            <a:srgbClr val="102A43"/>
+          </a:solidFill>
+          <a:ln w="12700">
+            <a:solidFill>
+              <a:srgbClr val="102A43"/>
+            </a:solidFill>
+            <a:prstDash val="solid"/>
+          </a:ln>
+        </p:spPr>
+      </p:sp>
+      <p:sp>
+        <p:nvSpPr>
+          <p:cNvPr id="4" name="Shape 2"/>
+          <p:cNvSpPr/>
+          <p:nvPr/>
+        </p:nvSpPr>
+        <p:spPr>
+          <a:xfrm>
+            <a:off x="1243584" y="0"/>
+            <a:ext cx="256032" cy="109728"/>
+          </a:xfrm>
+          <a:prstGeom prst="rect">
+            <a:avLst/>
+          </a:prstGeom>
+          <a:solidFill>
+            <a:srgbClr val="E0BC5A"/>
+          </a:solidFill>
+          <a:ln w="12700">
+            <a:solidFill>
+              <a:srgbClr val="E0BC5A"/>
+            </a:solidFill>
+            <a:prstDash val="solid"/>
+          </a:ln>
+        </p:spPr>
+      </p:sp>
+      <p:pic>
+        <p:nvPicPr>
+          <p:cNvPr id="5" name="Image 0" descr="C:\Users\Diego Obando\dev\tpe401-taller-de-proyecto-de-especialidad\clases\semana-01\01\ppt\source\assets\logo-aiep.svg">    </p:cNvPr>
+          <p:cNvPicPr>
+            <a:picLocks noChangeAspect="1"/>
+          </p:cNvPicPr>
+          <p:nvPr/>
+        </p:nvPicPr>
+        <p:blipFill>
+          <a:blip r:embed="rId1">
+            <a:extLst>
+              <a:ext uri="{96DAC541-7B7A-43D3-8B79-37D633B846F1}">
+                <asvg:svgBlip xmlns:asvg="http://schemas.microsoft.com/office/drawing/2016/SVG/main" r:embed="rId2"/>
+              </a:ext>
+            </a:extLst>
+          </a:blip>
+          <a:stretch>
+            <a:fillRect/>
+          </a:stretch>
+        </p:blipFill>
+        <p:spPr>
+          <a:xfrm>
+            <a:off x="10222992" y="306941"/>
+            <a:ext cx="1335024" cy="465110"/>
+          </a:xfrm>
+          <a:prstGeom prst="rect">
+            <a:avLst/>
+          </a:prstGeom>
+        </p:spPr>
+      </p:pic>
+      <p:sp>
+        <p:nvSpPr>
+          <p:cNvPr id="6" name="Text 3"/>
+          <p:cNvSpPr txBox="1"/>
+          <p:nvPr/>
+        </p:nvSpPr>
+        <p:spPr>
+          <a:xfrm>
+            <a:off x="658368" y="6492240"/>
+            <a:ext cx="5669280" cy="164592"/>
+          </a:xfrm>
+          <a:prstGeom prst="rect">
+            <a:avLst/>
+          </a:prstGeom>
+          <a:noFill/>
+          <a:ln/>
+        </p:spPr>
+        <p:txBody>
+          <a:bodyPr wrap="square" lIns="0" tIns="0" rIns="0" bIns="0" rtlCol="0" anchor="t"/>
+          <a:lstStyle/>
+          <a:p>
+            <a:pPr algn="l" indent="0" marL="0">
+              <a:buNone/>
+            </a:pPr>
+            <a:r>
+              <a:rPr lang="en-US" sz="950" b="1" spc="55" kern="0" dirty="0">
+                <a:solidFill>
+                  <a:srgbClr val="52606D"/>
+                </a:solidFill>
+                <a:latin typeface="Aptos" pitchFamily="34" charset="0"/>
+                <a:ea typeface="Aptos" pitchFamily="34" charset="-122"/>
+                <a:cs typeface="Aptos" pitchFamily="34" charset="-120"/>
+              </a:rPr>
+              <a:t>TPE401 · Taller de Proyecto de Especialidad</a:t>
+            </a:r>
+            <a:endParaRPr lang="en-US" sz="950" dirty="0"/>
+          </a:p>
+        </p:txBody>
+      </p:sp>
+      <p:sp>
+        <p:nvSpPr>
+          <p:cNvPr id="7" name="Text 4"/>
+          <p:cNvSpPr txBox="1"/>
+          <p:nvPr/>
+        </p:nvSpPr>
+        <p:spPr>
+          <a:xfrm>
+            <a:off x="10716768" y="6419088"/>
+            <a:ext cx="822960" cy="256032"/>
+          </a:xfrm>
+          <a:prstGeom prst="rect">
+            <a:avLst/>
+          </a:prstGeom>
+          <a:noFill/>
+          <a:ln/>
+        </p:spPr>
+        <p:txBody>
+          <a:bodyPr wrap="square" lIns="0" tIns="0" rIns="0" bIns="0" rtlCol="0" anchor="t"/>
+          <a:lstStyle/>
+          <a:p>
+            <a:pPr algn="r" indent="0" marL="0">
+              <a:buNone/>
+            </a:pPr>
+            <a:r>
+              <a:rPr lang="en-US" sz="1400" b="1" dirty="0">
+                <a:solidFill>
+                  <a:srgbClr val="243B53"/>
+                </a:solidFill>
+                <a:latin typeface="Aptos Display" pitchFamily="34" charset="0"/>
+                <a:ea typeface="Aptos Display" pitchFamily="34" charset="-122"/>
+                <a:cs typeface="Aptos Display" pitchFamily="34" charset="-120"/>
+              </a:rPr>
+              <a:t>30</a:t>
+            </a:r>
+            <a:endParaRPr lang="en-US" sz="1400" dirty="0"/>
+          </a:p>
+        </p:txBody>
+      </p:sp>
+      <p:sp>
+        <p:nvSpPr>
+          <p:cNvPr id="8" name="Text 5"/>
+          <p:cNvSpPr txBox="1"/>
+          <p:nvPr/>
+        </p:nvSpPr>
+        <p:spPr>
+          <a:xfrm>
+            <a:off x="658368" y="402336"/>
+            <a:ext cx="7132320" cy="201168"/>
+          </a:xfrm>
+          <a:prstGeom prst="rect">
+            <a:avLst/>
+          </a:prstGeom>
+          <a:noFill/>
+          <a:ln/>
+        </p:spPr>
+        <p:txBody>
+          <a:bodyPr wrap="square" lIns="0" tIns="0" rIns="0" bIns="0" rtlCol="0" anchor="t"/>
+          <a:lstStyle/>
+          <a:p>
+            <a:pPr algn="l" indent="0" marL="0">
+              <a:buNone/>
+            </a:pPr>
+            <a:r>
+              <a:rPr lang="en-US" sz="1030" b="1" spc="170" kern="0" dirty="0">
+                <a:solidFill>
+                  <a:srgbClr val="D62027"/>
+                </a:solidFill>
+                <a:latin typeface="Aptos" pitchFamily="34" charset="0"/>
+                <a:ea typeface="Aptos" pitchFamily="34" charset="-122"/>
+                <a:cs typeface="Aptos" pitchFamily="34" charset="-120"/>
+              </a:rPr>
+              <a:t>EL TRABAJO DEL EQUIPO</a:t>
+            </a:r>
+            <a:endParaRPr lang="en-US" sz="1030" dirty="0"/>
+          </a:p>
+        </p:txBody>
+      </p:sp>
+      <p:sp>
+        <p:nvSpPr>
+          <p:cNvPr id="9" name="Text 6"/>
+          <p:cNvSpPr txBox="1"/>
+          <p:nvPr/>
+        </p:nvSpPr>
+        <p:spPr>
+          <a:xfrm>
+            <a:off x="658368" y="749808"/>
+            <a:ext cx="9326880" cy="841248"/>
+          </a:xfrm>
+          <a:prstGeom prst="rect">
+            <a:avLst/>
+          </a:prstGeom>
+          <a:noFill/>
+          <a:ln/>
+        </p:spPr>
+        <p:txBody>
+          <a:bodyPr wrap="square" lIns="0" tIns="0" rIns="0" bIns="0" rtlCol="0" anchor="t"/>
+          <a:lstStyle/>
+          <a:p>
+            <a:pPr algn="l" indent="0" marL="0">
+              <a:lnSpc>
+                <a:spcPct val="103000"/>
+              </a:lnSpc>
+              <a:buNone/>
+            </a:pPr>
+            <a:r>
+              <a:rPr lang="en-US" sz="2800" b="1" dirty="0">
+                <a:solidFill>
+                  <a:srgbClr val="243B53"/>
+                </a:solidFill>
+                <a:latin typeface="Aptos Display" pitchFamily="34" charset="0"/>
+                <a:ea typeface="Aptos Display" pitchFamily="34" charset="-122"/>
+                <a:cs typeface="Aptos Display" pitchFamily="34" charset="-120"/>
+              </a:rPr>
+              <a:t>Avanzar mientras se gestiona el contacto</a:t>
+            </a:r>
+            <a:endParaRPr lang="en-US" sz="2800" dirty="0"/>
+          </a:p>
+        </p:txBody>
+      </p:sp>
+      <p:sp>
+        <p:nvSpPr>
+          <p:cNvPr id="10" name="Text 7"/>
+          <p:cNvSpPr txBox="1"/>
+          <p:nvPr/>
+        </p:nvSpPr>
+        <p:spPr>
+          <a:xfrm>
+            <a:off x="658368" y="1609344"/>
+            <a:ext cx="10874959" cy="594360"/>
+          </a:xfrm>
+          <a:prstGeom prst="rect">
+            <a:avLst/>
+          </a:prstGeom>
+          <a:noFill/>
+          <a:ln/>
+        </p:spPr>
+        <p:txBody>
+          <a:bodyPr wrap="square" lIns="0" tIns="0" rIns="0" bIns="0" rtlCol="0" anchor="t"/>
+          <a:lstStyle/>
+          <a:p>
+            <a:pPr algn="l" indent="0" marL="0">
+              <a:buNone/>
+            </a:pPr>
+            <a:r>
+              <a:rPr lang="en-US" sz="2400" b="1" dirty="0">
+                <a:solidFill>
+                  <a:srgbClr val="102A43"/>
+                </a:solidFill>
+                <a:latin typeface="Aptos" pitchFamily="34" charset="0"/>
+                <a:ea typeface="Aptos" pitchFamily="34" charset="-122"/>
+                <a:cs typeface="Aptos" pitchFamily="34" charset="-120"/>
+              </a:rPr>
+              <a:t>Se puede comenzar y entregar sin contacto con la organización.</a:t>
+            </a:r>
+            <a:endParaRPr lang="en-US" sz="2400" dirty="0"/>
+          </a:p>
+        </p:txBody>
+      </p:sp>
+      <p:sp>
+        <p:nvSpPr>
+          <p:cNvPr id="11" name="Shape 8"/>
+          <p:cNvSpPr/>
+          <p:nvPr/>
+        </p:nvSpPr>
+        <p:spPr>
+          <a:xfrm>
+            <a:off x="658368" y="2468880"/>
+            <a:ext cx="64008" cy="731520"/>
+          </a:xfrm>
+          <a:prstGeom prst="rect">
+            <a:avLst/>
+          </a:prstGeom>
+          <a:solidFill>
+            <a:srgbClr val="D62027"/>
+          </a:solidFill>
+          <a:ln w="12700">
+            <a:solidFill>
+              <a:srgbClr val="D62027"/>
+            </a:solidFill>
+            <a:prstDash val="solid"/>
+          </a:ln>
+        </p:spPr>
+      </p:sp>
+      <p:sp>
+        <p:nvSpPr>
+          <p:cNvPr id="12" name="Text 9"/>
+          <p:cNvSpPr txBox="1"/>
+          <p:nvPr/>
+        </p:nvSpPr>
+        <p:spPr>
+          <a:xfrm>
+            <a:off x="859536" y="2468880"/>
+            <a:ext cx="2834640" cy="640080"/>
+          </a:xfrm>
+          <a:prstGeom prst="rect">
+            <a:avLst/>
+          </a:prstGeom>
+          <a:noFill/>
+          <a:ln/>
+        </p:spPr>
+        <p:txBody>
+          <a:bodyPr wrap="square" lIns="0" tIns="0" rIns="0" bIns="0" rtlCol="0" anchor="ctr"/>
+          <a:lstStyle/>
+          <a:p>
+            <a:pPr algn="l" indent="0" marL="0">
+              <a:buNone/>
+            </a:pPr>
+            <a:r>
+              <a:rPr lang="en-US" sz="1800" b="1" dirty="0">
+                <a:solidFill>
+                  <a:srgbClr val="102A43"/>
+                </a:solidFill>
+                <a:latin typeface="Aptos" pitchFamily="34" charset="0"/>
+                <a:ea typeface="Aptos" pitchFamily="34" charset="-122"/>
+                <a:cs typeface="Aptos" pitchFamily="34" charset="-120"/>
+              </a:rPr>
+              <a:t>Ahora</a:t>
+            </a:r>
+            <a:endParaRPr lang="en-US" sz="1800" dirty="0"/>
+          </a:p>
+        </p:txBody>
+      </p:sp>
+      <p:sp>
+        <p:nvSpPr>
+          <p:cNvPr id="13" name="Text 10"/>
+          <p:cNvSpPr txBox="1"/>
+          <p:nvPr/>
+        </p:nvSpPr>
+        <p:spPr>
+          <a:xfrm>
+            <a:off x="3950208" y="2468880"/>
+            <a:ext cx="7583119" cy="749808"/>
+          </a:xfrm>
+          <a:prstGeom prst="rect">
+            <a:avLst/>
+          </a:prstGeom>
+          <a:noFill/>
+          <a:ln/>
+        </p:spPr>
+        <p:txBody>
+          <a:bodyPr wrap="square" lIns="0" tIns="0" rIns="0" bIns="0" rtlCol="0" anchor="ctr"/>
+          <a:lstStyle/>
+          <a:p>
+            <a:pPr algn="l" indent="0" marL="0">
+              <a:buNone/>
+            </a:pPr>
+            <a:r>
+              <a:rPr lang="en-US" sz="1700" dirty="0">
+                <a:solidFill>
+                  <a:srgbClr val="243B53"/>
+                </a:solidFill>
+                <a:latin typeface="Aptos" pitchFamily="34" charset="0"/>
+                <a:ea typeface="Aptos" pitchFamily="34" charset="-122"/>
+                <a:cs typeface="Aptos" pitchFamily="34" charset="-120"/>
+              </a:rPr>
+              <a:t>Analizar el caso real que entrega el docente y las fuentes disponibles. Identificar y justificar los supuestos que permiten diseñar y desarrollar.</a:t>
+            </a:r>
+            <a:endParaRPr lang="en-US" sz="1700" dirty="0"/>
+          </a:p>
+        </p:txBody>
+      </p:sp>
+      <p:sp>
+        <p:nvSpPr>
+          <p:cNvPr id="14" name="Shape 11"/>
+          <p:cNvSpPr/>
+          <p:nvPr/>
+        </p:nvSpPr>
+        <p:spPr>
+          <a:xfrm>
+            <a:off x="658368" y="3383280"/>
+            <a:ext cx="64008" cy="731520"/>
+          </a:xfrm>
+          <a:prstGeom prst="rect">
+            <a:avLst/>
+          </a:prstGeom>
+          <a:solidFill>
+            <a:srgbClr val="284B75"/>
+          </a:solidFill>
+          <a:ln w="12700">
+            <a:solidFill>
+              <a:srgbClr val="284B75"/>
+            </a:solidFill>
+            <a:prstDash val="solid"/>
+          </a:ln>
+        </p:spPr>
+      </p:sp>
+      <p:sp>
+        <p:nvSpPr>
+          <p:cNvPr id="15" name="Text 12"/>
+          <p:cNvSpPr txBox="1"/>
+          <p:nvPr/>
+        </p:nvSpPr>
+        <p:spPr>
+          <a:xfrm>
+            <a:off x="859536" y="3383280"/>
+            <a:ext cx="2834640" cy="640080"/>
+          </a:xfrm>
+          <a:prstGeom prst="rect">
+            <a:avLst/>
+          </a:prstGeom>
+          <a:noFill/>
+          <a:ln/>
+        </p:spPr>
+        <p:txBody>
+          <a:bodyPr wrap="square" lIns="0" tIns="0" rIns="0" bIns="0" rtlCol="0" anchor="ctr"/>
+          <a:lstStyle/>
+          <a:p>
+            <a:pPr algn="l" indent="0" marL="0">
+              <a:buNone/>
+            </a:pPr>
+            <a:r>
+              <a:rPr lang="en-US" sz="1800" b="1" dirty="0">
+                <a:solidFill>
+                  <a:srgbClr val="102A43"/>
+                </a:solidFill>
+                <a:latin typeface="Aptos" pitchFamily="34" charset="0"/>
+                <a:ea typeface="Aptos" pitchFamily="34" charset="-122"/>
+                <a:cs typeface="Aptos" pitchFamily="34" charset="-120"/>
+              </a:rPr>
+              <a:t>Si se habilita el contacto</a:t>
+            </a:r>
+            <a:endParaRPr lang="en-US" sz="1800" dirty="0"/>
+          </a:p>
+        </p:txBody>
+      </p:sp>
+      <p:sp>
+        <p:nvSpPr>
+          <p:cNvPr id="16" name="Text 13"/>
+          <p:cNvSpPr txBox="1"/>
+          <p:nvPr/>
+        </p:nvSpPr>
+        <p:spPr>
+          <a:xfrm>
+            <a:off x="3950208" y="3383280"/>
+            <a:ext cx="7583119" cy="749808"/>
+          </a:xfrm>
+          <a:prstGeom prst="rect">
+            <a:avLst/>
+          </a:prstGeom>
+          <a:noFill/>
+          <a:ln/>
+        </p:spPr>
+        <p:txBody>
+          <a:bodyPr wrap="square" lIns="0" tIns="0" rIns="0" bIns="0" rtlCol="0" anchor="ctr"/>
+          <a:lstStyle/>
+          <a:p>
+            <a:pPr algn="l" indent="0" marL="0">
+              <a:buNone/>
+            </a:pPr>
+            <a:r>
+              <a:rPr lang="en-US" sz="1700" dirty="0">
+                <a:solidFill>
+                  <a:srgbClr val="243B53"/>
+                </a:solidFill>
+                <a:latin typeface="Aptos" pitchFamily="34" charset="0"/>
+                <a:ea typeface="Aptos" pitchFamily="34" charset="-122"/>
+                <a:cs typeface="Aptos" pitchFamily="34" charset="-120"/>
+              </a:rPr>
+              <a:t>Conversar con la organización y contrastar los supuestos. Registrar qué se confirma, qué cambia y qué sigue pendiente.</a:t>
+            </a:r>
+            <a:endParaRPr lang="en-US" sz="1700" dirty="0"/>
+          </a:p>
+        </p:txBody>
+      </p:sp>
+      <p:sp>
+        <p:nvSpPr>
+          <p:cNvPr id="17" name="Shape 14"/>
+          <p:cNvSpPr/>
+          <p:nvPr/>
+        </p:nvSpPr>
+        <p:spPr>
+          <a:xfrm>
+            <a:off x="658368" y="4297680"/>
+            <a:ext cx="64008" cy="731520"/>
+          </a:xfrm>
+          <a:prstGeom prst="rect">
+            <a:avLst/>
+          </a:prstGeom>
+          <a:solidFill>
+            <a:srgbClr val="E0BC5A"/>
+          </a:solidFill>
+          <a:ln w="12700">
+            <a:solidFill>
+              <a:srgbClr val="E0BC5A"/>
+            </a:solidFill>
+            <a:prstDash val="solid"/>
+          </a:ln>
+        </p:spPr>
+      </p:sp>
+      <p:sp>
+        <p:nvSpPr>
+          <p:cNvPr id="18" name="Text 15"/>
+          <p:cNvSpPr txBox="1"/>
+          <p:nvPr/>
+        </p:nvSpPr>
+        <p:spPr>
+          <a:xfrm>
+            <a:off x="859536" y="4297680"/>
+            <a:ext cx="2834640" cy="640080"/>
+          </a:xfrm>
+          <a:prstGeom prst="rect">
+            <a:avLst/>
+          </a:prstGeom>
+          <a:noFill/>
+          <a:ln/>
+        </p:spPr>
+        <p:txBody>
+          <a:bodyPr wrap="square" lIns="0" tIns="0" rIns="0" bIns="0" rtlCol="0" anchor="ctr"/>
+          <a:lstStyle/>
+          <a:p>
+            <a:pPr algn="l" indent="0" marL="0">
+              <a:buNone/>
+            </a:pPr>
+            <a:r>
+              <a:rPr lang="en-US" sz="1800" b="1" dirty="0">
+                <a:solidFill>
+                  <a:srgbClr val="102A43"/>
+                </a:solidFill>
+                <a:latin typeface="Aptos" pitchFamily="34" charset="0"/>
+                <a:ea typeface="Aptos" pitchFamily="34" charset="-122"/>
+                <a:cs typeface="Aptos" pitchFamily="34" charset="-120"/>
+              </a:rPr>
+              <a:t>Actualizar y entregar</a:t>
+            </a:r>
+            <a:endParaRPr lang="en-US" sz="1800" dirty="0"/>
+          </a:p>
+        </p:txBody>
+      </p:sp>
+      <p:sp>
+        <p:nvSpPr>
+          <p:cNvPr id="19" name="Text 16"/>
+          <p:cNvSpPr txBox="1"/>
+          <p:nvPr/>
+        </p:nvSpPr>
+        <p:spPr>
+          <a:xfrm>
+            <a:off x="3950208" y="4297680"/>
+            <a:ext cx="7583119" cy="749808"/>
+          </a:xfrm>
+          <a:prstGeom prst="rect">
+            <a:avLst/>
+          </a:prstGeom>
+          <a:noFill/>
+          <a:ln/>
+        </p:spPr>
+        <p:txBody>
+          <a:bodyPr wrap="square" lIns="0" tIns="0" rIns="0" bIns="0" rtlCol="0" anchor="ctr"/>
+          <a:lstStyle/>
+          <a:p>
+            <a:pPr algn="l" indent="0" marL="0">
+              <a:buNone/>
+            </a:pPr>
+            <a:r>
+              <a:rPr lang="en-US" sz="1700" dirty="0">
+                <a:solidFill>
+                  <a:srgbClr val="243B53"/>
+                </a:solidFill>
+                <a:latin typeface="Aptos" pitchFamily="34" charset="0"/>
+                <a:ea typeface="Aptos" pitchFamily="34" charset="-122"/>
+                <a:cs typeface="Aptos" pitchFamily="34" charset="-120"/>
+              </a:rPr>
+              <a:t>Reflejar los cambios en la propuesta y el software. Si no hay contacto, entregar lo desarrollado con evidencias y pendientes declarados.</a:t>
+            </a:r>
+            <a:endParaRPr lang="en-US" sz="1700" dirty="0"/>
+          </a:p>
+        </p:txBody>
+      </p:sp>
+      <p:sp>
+        <p:nvSpPr>
+          <p:cNvPr id="20" name="Shape 17"/>
+          <p:cNvSpPr/>
+          <p:nvPr/>
+        </p:nvSpPr>
+        <p:spPr>
+          <a:xfrm>
+            <a:off x="658368" y="5632704"/>
+            <a:ext cx="10874959" cy="530352"/>
+          </a:xfrm>
+          <a:prstGeom prst="rect">
+            <a:avLst/>
+          </a:prstGeom>
+          <a:solidFill>
+            <a:srgbClr val="102A43"/>
+          </a:solidFill>
+          <a:ln w="12700">
+            <a:solidFill>
+              <a:srgbClr val="102A43"/>
+            </a:solidFill>
+            <a:prstDash val="solid"/>
+          </a:ln>
+        </p:spPr>
+      </p:sp>
+      <p:sp>
+        <p:nvSpPr>
+          <p:cNvPr id="21" name="Text 18"/>
+          <p:cNvSpPr txBox="1"/>
+          <p:nvPr/>
+        </p:nvSpPr>
+        <p:spPr>
+          <a:xfrm>
+            <a:off x="950976" y="5678424"/>
+            <a:ext cx="10289743" cy="438912"/>
+          </a:xfrm>
+          <a:prstGeom prst="rect">
+            <a:avLst/>
+          </a:prstGeom>
+          <a:noFill/>
+          <a:ln/>
+        </p:spPr>
+        <p:txBody>
+          <a:bodyPr wrap="square" lIns="0" tIns="0" rIns="0" bIns="0" rtlCol="0" anchor="ctr"/>
+          <a:lstStyle/>
+          <a:p>
+            <a:pPr algn="ctr" indent="0" marL="0">
+              <a:lnSpc>
+                <a:spcPct val="110000"/>
+              </a:lnSpc>
+              <a:buNone/>
+            </a:pPr>
+            <a:r>
+              <a:rPr lang="en-US" sz="1400" b="1" dirty="0">
+                <a:solidFill>
+                  <a:srgbClr val="FFFFFF"/>
+                </a:solidFill>
+                <a:latin typeface="Aptos" pitchFamily="34" charset="0"/>
+                <a:ea typeface="Aptos" pitchFamily="34" charset="-122"/>
+                <a:cs typeface="Aptos" pitchFamily="34" charset="-120"/>
+              </a:rPr>
+              <a:t>Supuesto: afirmación provisional por comprobar. Las fechas de entrega se mantienen.</a:t>
+            </a:r>
+            <a:endParaRPr lang="en-US" sz="1400" dirty="0"/>
+          </a:p>
+        </p:txBody>
+      </p:sp>
+    </p:spTree>
+  </p:cSld>
+  <p:clrMapOvr>
+    <a:masterClrMapping/>
+  </p:clrMapOvr>
+</p:sld>
+</file>
+
+<file path=ppt/slides/slide31.xml><?xml version="1.0" encoding="utf-8"?>
+<p:sld xmlns:a="http://schemas.openxmlformats.org/drawingml/2006/main" xmlns:r="http://schemas.openxmlformats.org/officeDocument/2006/relationships" xmlns:p="http://schemas.openxmlformats.org/presentationml/2006/main">
+  <p:cSld name="Slide 31">
+    <p:bg>
+      <p:bgPr>
+        <a:solidFill>
           <a:srgbClr val="102A43"/>
         </a:solidFill>
       </p:bgPr>
@@ -32302,7 +33102,7 @@
                 <a:ea typeface="Aptos Display" pitchFamily="34" charset="-122"/>
                 <a:cs typeface="Aptos Display" pitchFamily="34" charset="-120"/>
               </a:rPr>
-              <a:t>30</a:t>
+              <a:t>31</a:t>
             </a:r>
             <a:endParaRPr lang="en-US" sz="1400" dirty="0"/>
           </a:p>

</xml_diff>